<commit_message>
Update data model slide with 3 dynamic tables
Slide 5 table now shows all 8 objects: 5 source tables + 3 dynamic tables
(CUSTOMER_360_VIEW, CHURN_SIGNALS_EXPLAINED, NEXT_BEST_ACTION) with blue
highlighting and 10-min refresh label. Governance note updated.

Generated with [Snowflake CoCo](https://docs.snowflake.com/en/user-guide/cortex-code/cortex-code)

Co-authored-by: Snowflake CoCo <noreply@snowflake.com>
</commit_message>
<xml_diff>
--- a/Customer360_AI_Presentation_Updated.pptx
+++ b/Customer360_AI_Presentation_Updated.pptx
@@ -8507,7 +8507,7 @@
         </p:nvGraphicFramePr>
         <p:xfrm>
           <a:off x="466725" y="1533525"/>
-          <a:ext cx="11258547" cy="2383631"/>
+          <a:ext cx="11258547" cy="3583631"/>
         </p:xfrm>
         <a:graphic>
           <a:graphicData uri="http://schemas.openxmlformats.org/drawingml/2006/table">
@@ -9391,6 +9391,432 @@
                   </a:tcPr>
                 </a:tc>
               </a:tr>
+              <a:tr h="397276">
+                <a:tc>
+                  <a:txBody>
+                    <a:bodyPr/>
+                    <a:lstStyle/>
+                    <a:p>
+                      <a:pPr algn="l"/>
+                      <a:r>
+                        <a:rPr b="1" sz="1012" i="0" u="none">
+                          <a:solidFill>
+                            <a:srgbClr val="3498DB"/>
+                          </a:solidFill>
+                          <a:latin typeface="Inter"/>
+                        </a:rPr>
+                        <a:t>CUSTOMER_360_VIEW</a:t>
+                      </a:r>
+                    </a:p>
+                  </a:txBody>
+                  <a:tcPr anchor="ctr" marL="63500" marR="63500" marT="25400" marB="25400">
+                    <a:lnL>
+                      <a:noFill/>
+                    </a:lnL>
+                    <a:lnR>
+                      <a:noFill/>
+                    </a:lnR>
+                    <a:lnT>
+                      <a:noFill/>
+                    </a:lnT>
+                    <a:lnB>
+                      <a:noFill/>
+                    </a:lnB>
+                    <a:solidFill>
+                      <a:srgbClr val="EBF5FB"/>
+                    </a:solidFill>
+                  </a:tcPr>
+                </a:tc>
+                <a:tc>
+                  <a:txBody>
+                    <a:bodyPr/>
+                    <a:lstStyle/>
+                    <a:p>
+                      <a:pPr algn="l"/>
+                      <a:r>
+                        <a:rPr b="0" sz="1012" i="0" u="none">
+                          <a:solidFill>
+                            <a:srgbClr val="3498DB"/>
+                          </a:solidFill>
+                          <a:latin typeface="Inter"/>
+                        </a:rPr>
+                        <a:t>500</a:t>
+                      </a:r>
+                    </a:p>
+                  </a:txBody>
+                  <a:tcPr anchor="ctr" marL="63500" marR="63500" marT="25400" marB="25400">
+                    <a:lnL>
+                      <a:noFill/>
+                    </a:lnL>
+                    <a:lnR>
+                      <a:noFill/>
+                    </a:lnR>
+                    <a:lnT>
+                      <a:noFill/>
+                    </a:lnT>
+                    <a:lnB>
+                      <a:noFill/>
+                    </a:lnB>
+                    <a:solidFill>
+                      <a:srgbClr val="EBF5FB"/>
+                    </a:solidFill>
+                  </a:tcPr>
+                </a:tc>
+                <a:tc>
+                  <a:txBody>
+                    <a:bodyPr/>
+                    <a:lstStyle/>
+                    <a:p>
+                      <a:pPr algn="l"/>
+                      <a:r>
+                        <a:rPr b="0" sz="1012" i="0" u="none">
+                          <a:solidFill>
+                            <a:srgbClr val="3498DB"/>
+                          </a:solidFill>
+                          <a:latin typeface="Inter"/>
+                        </a:rPr>
+                        <a:t>Unified customer view with 9-signal churn risk scoring, health score</a:t>
+                      </a:r>
+                    </a:p>
+                  </a:txBody>
+                  <a:tcPr anchor="ctr" marL="63500" marR="63500" marT="25400" marB="25400">
+                    <a:lnL>
+                      <a:noFill/>
+                    </a:lnL>
+                    <a:lnR>
+                      <a:noFill/>
+                    </a:lnR>
+                    <a:lnT>
+                      <a:noFill/>
+                    </a:lnT>
+                    <a:lnB>
+                      <a:noFill/>
+                    </a:lnB>
+                    <a:solidFill>
+                      <a:srgbClr val="EBF5FB"/>
+                    </a:solidFill>
+                  </a:tcPr>
+                </a:tc>
+                <a:tc>
+                  <a:txBody>
+                    <a:bodyPr/>
+                    <a:lstStyle/>
+                    <a:p>
+                      <a:pPr algn="l"/>
+                      <a:r>
+                        <a:rPr b="0" sz="1012" i="0" u="none">
+                          <a:solidFill>
+                            <a:srgbClr val="3498DB"/>
+                          </a:solidFill>
+                          <a:latin typeface="Inter"/>
+                        </a:rPr>
+                        <a:t>Dynamic Table (10-min refresh)</a:t>
+                      </a:r>
+                    </a:p>
+                  </a:txBody>
+                  <a:tcPr anchor="ctr" marL="63500" marR="63500" marT="25400" marB="25400">
+                    <a:lnL>
+                      <a:noFill/>
+                    </a:lnL>
+                    <a:lnR>
+                      <a:noFill/>
+                    </a:lnR>
+                    <a:lnT>
+                      <a:noFill/>
+                    </a:lnT>
+                    <a:lnB>
+                      <a:noFill/>
+                    </a:lnB>
+                    <a:solidFill>
+                      <a:srgbClr val="EBF5FB"/>
+                    </a:solidFill>
+                  </a:tcPr>
+                </a:tc>
+              </a:tr>
+              <a:tr h="397276">
+                <a:tc>
+                  <a:txBody>
+                    <a:bodyPr/>
+                    <a:lstStyle/>
+                    <a:p>
+                      <a:pPr algn="l"/>
+                      <a:r>
+                        <a:rPr b="1" sz="1012" i="0" u="none">
+                          <a:solidFill>
+                            <a:srgbClr val="3498DB"/>
+                          </a:solidFill>
+                          <a:latin typeface="Inter"/>
+                        </a:rPr>
+                        <a:t>CHURN_SIGNALS_EXPLAINED</a:t>
+                      </a:r>
+                    </a:p>
+                  </a:txBody>
+                  <a:tcPr anchor="ctr" marL="63500" marR="63500" marT="25400" marB="25400">
+                    <a:lnL>
+                      <a:noFill/>
+                    </a:lnL>
+                    <a:lnR>
+                      <a:noFill/>
+                    </a:lnR>
+                    <a:lnT>
+                      <a:noFill/>
+                    </a:lnT>
+                    <a:lnB>
+                      <a:noFill/>
+                    </a:lnB>
+                    <a:solidFill>
+                      <a:srgbClr val="EBF5FB"/>
+                    </a:solidFill>
+                  </a:tcPr>
+                </a:tc>
+                <a:tc>
+                  <a:txBody>
+                    <a:bodyPr/>
+                    <a:lstStyle/>
+                    <a:p>
+                      <a:pPr algn="l"/>
+                      <a:r>
+                        <a:rPr b="0" sz="1012" i="0" u="none">
+                          <a:solidFill>
+                            <a:srgbClr val="3498DB"/>
+                          </a:solidFill>
+                          <a:latin typeface="Inter"/>
+                        </a:rPr>
+                        <a:t>500</a:t>
+                      </a:r>
+                    </a:p>
+                  </a:txBody>
+                  <a:tcPr anchor="ctr" marL="63500" marR="63500" marT="25400" marB="25400">
+                    <a:lnL>
+                      <a:noFill/>
+                    </a:lnL>
+                    <a:lnR>
+                      <a:noFill/>
+                    </a:lnR>
+                    <a:lnT>
+                      <a:noFill/>
+                    </a:lnT>
+                    <a:lnB>
+                      <a:noFill/>
+                    </a:lnB>
+                    <a:solidFill>
+                      <a:srgbClr val="EBF5FB"/>
+                    </a:solidFill>
+                  </a:tcPr>
+                </a:tc>
+                <a:tc>
+                  <a:txBody>
+                    <a:bodyPr/>
+                    <a:lstStyle/>
+                    <a:p>
+                      <a:pPr algn="l"/>
+                      <a:r>
+                        <a:rPr b="0" sz="1012" i="0" u="none">
+                          <a:solidFill>
+                            <a:srgbClr val="3498DB"/>
+                          </a:solidFill>
+                          <a:latin typeface="Inter"/>
+                        </a:rPr>
+                        <a:t>Explainable churn drivers per customer with signal levels</a:t>
+                      </a:r>
+                    </a:p>
+                  </a:txBody>
+                  <a:tcPr anchor="ctr" marL="63500" marR="63500" marT="25400" marB="25400">
+                    <a:lnL>
+                      <a:noFill/>
+                    </a:lnL>
+                    <a:lnR>
+                      <a:noFill/>
+                    </a:lnR>
+                    <a:lnT>
+                      <a:noFill/>
+                    </a:lnT>
+                    <a:lnB>
+                      <a:noFill/>
+                    </a:lnB>
+                    <a:solidFill>
+                      <a:srgbClr val="EBF5FB"/>
+                    </a:solidFill>
+                  </a:tcPr>
+                </a:tc>
+                <a:tc>
+                  <a:txBody>
+                    <a:bodyPr/>
+                    <a:lstStyle/>
+                    <a:p>
+                      <a:pPr algn="l"/>
+                      <a:r>
+                        <a:rPr b="0" sz="1012" i="0" u="none">
+                          <a:solidFill>
+                            <a:srgbClr val="3498DB"/>
+                          </a:solidFill>
+                          <a:latin typeface="Inter"/>
+                        </a:rPr>
+                        <a:t>Dynamic Table (10-min refresh)</a:t>
+                      </a:r>
+                    </a:p>
+                  </a:txBody>
+                  <a:tcPr anchor="ctr" marL="63500" marR="63500" marT="25400" marB="25400">
+                    <a:lnL>
+                      <a:noFill/>
+                    </a:lnL>
+                    <a:lnR>
+                      <a:noFill/>
+                    </a:lnR>
+                    <a:lnT>
+                      <a:noFill/>
+                    </a:lnT>
+                    <a:lnB>
+                      <a:noFill/>
+                    </a:lnB>
+                    <a:solidFill>
+                      <a:srgbClr val="EBF5FB"/>
+                    </a:solidFill>
+                  </a:tcPr>
+                </a:tc>
+              </a:tr>
+              <a:tr h="397276">
+                <a:tc>
+                  <a:txBody>
+                    <a:bodyPr/>
+                    <a:lstStyle/>
+                    <a:p>
+                      <a:pPr algn="l"/>
+                      <a:r>
+                        <a:rPr b="1" sz="1012" i="0" u="none">
+                          <a:solidFill>
+                            <a:srgbClr val="3498DB"/>
+                          </a:solidFill>
+                          <a:latin typeface="Inter"/>
+                        </a:rPr>
+                        <a:t>NEXT_BEST_ACTION</a:t>
+                      </a:r>
+                    </a:p>
+                  </a:txBody>
+                  <a:tcPr anchor="ctr" marL="63500" marR="63500" marT="25400" marB="25400">
+                    <a:lnL>
+                      <a:noFill/>
+                    </a:lnL>
+                    <a:lnR>
+                      <a:noFill/>
+                    </a:lnR>
+                    <a:lnT>
+                      <a:noFill/>
+                    </a:lnT>
+                    <a:lnB>
+                      <a:noFill/>
+                    </a:lnB>
+                    <a:solidFill>
+                      <a:srgbClr val="EBF5FB"/>
+                    </a:solidFill>
+                  </a:tcPr>
+                </a:tc>
+                <a:tc>
+                  <a:txBody>
+                    <a:bodyPr/>
+                    <a:lstStyle/>
+                    <a:p>
+                      <a:pPr algn="l"/>
+                      <a:r>
+                        <a:rPr b="0" sz="1012" i="0" u="none">
+                          <a:solidFill>
+                            <a:srgbClr val="3498DB"/>
+                          </a:solidFill>
+                          <a:latin typeface="Inter"/>
+                        </a:rPr>
+                        <a:t>407</a:t>
+                      </a:r>
+                    </a:p>
+                  </a:txBody>
+                  <a:tcPr anchor="ctr" marL="63500" marR="63500" marT="25400" marB="25400">
+                    <a:lnL>
+                      <a:noFill/>
+                    </a:lnL>
+                    <a:lnR>
+                      <a:noFill/>
+                    </a:lnR>
+                    <a:lnT>
+                      <a:noFill/>
+                    </a:lnT>
+                    <a:lnB>
+                      <a:noFill/>
+                    </a:lnB>
+                    <a:solidFill>
+                      <a:srgbClr val="EBF5FB"/>
+                    </a:solidFill>
+                  </a:tcPr>
+                </a:tc>
+                <a:tc>
+                  <a:txBody>
+                    <a:bodyPr/>
+                    <a:lstStyle/>
+                    <a:p>
+                      <a:pPr algn="l"/>
+                      <a:r>
+                        <a:rPr b="0" sz="1012" i="0" u="none">
+                          <a:solidFill>
+                            <a:srgbClr val="3498DB"/>
+                          </a:solidFill>
+                          <a:latin typeface="Inter"/>
+                        </a:rPr>
+                        <a:t>Prioritized retention recommendations with suggested channel</a:t>
+                      </a:r>
+                    </a:p>
+                  </a:txBody>
+                  <a:tcPr anchor="ctr" marL="63500" marR="63500" marT="25400" marB="25400">
+                    <a:lnL>
+                      <a:noFill/>
+                    </a:lnL>
+                    <a:lnR>
+                      <a:noFill/>
+                    </a:lnR>
+                    <a:lnT>
+                      <a:noFill/>
+                    </a:lnT>
+                    <a:lnB>
+                      <a:noFill/>
+                    </a:lnB>
+                    <a:solidFill>
+                      <a:srgbClr val="EBF5FB"/>
+                    </a:solidFill>
+                  </a:tcPr>
+                </a:tc>
+                <a:tc>
+                  <a:txBody>
+                    <a:bodyPr/>
+                    <a:lstStyle/>
+                    <a:p>
+                      <a:pPr algn="l"/>
+                      <a:r>
+                        <a:rPr b="0" sz="1012" i="0" u="none">
+                          <a:solidFill>
+                            <a:srgbClr val="3498DB"/>
+                          </a:solidFill>
+                          <a:latin typeface="Inter"/>
+                        </a:rPr>
+                        <a:t>Dynamic Table (10-min refresh)</a:t>
+                      </a:r>
+                    </a:p>
+                  </a:txBody>
+                  <a:tcPr anchor="ctr" marL="63500" marR="63500" marT="25400" marB="25400">
+                    <a:lnL>
+                      <a:noFill/>
+                    </a:lnL>
+                    <a:lnR>
+                      <a:noFill/>
+                    </a:lnR>
+                    <a:lnT>
+                      <a:noFill/>
+                    </a:lnT>
+                    <a:lnB>
+                      <a:noFill/>
+                    </a:lnB>
+                    <a:solidFill>
+                      <a:srgbClr val="EBF5FB"/>
+                    </a:solidFill>
+                  </a:tcPr>
+                </a:tc>
+              </a:tr>
             </a:tbl>
           </a:graphicData>
         </a:graphic>
@@ -9429,7 +9855,7 @@
                 </a:solidFill>
                 <a:latin typeface="Inter"/>
               </a:rPr>
-              <a:t>Data Governance Note:</a:t>
+              <a:t>Data Governance Note: Synthetic data with 100% programmatically generated records. 3 Dynamic Tables (CUSTOMER_360_VIEW, CHURN_SIGNALS_EXPLAINED, NEXT_BEST_ACTION) auto-refresh every 10 minutes with pre-computed churn scores for instant app performance.</a:t>
             </a:r>
             <a:r>
               <a:rPr b="0" sz="1012" i="0" u="none">

</xml_diff>